<commit_message>
docs(legal): regenerate Plaid deck — Strategist replaces Drill Sergeant
Coach persona rename landed in Patet (jbrock1981/Plainly commit 9c35b28).
Mirror the user-facing copy in the partnership deck so slide 4 (AI coach
column) and slide 7 (unique features) reflect the current persona set:

  Older Sibling -> Strategist -> Therapist -> Hype Friend

Both .pptx and .pdf regenerated from their respective generators.

Co-Authored-By: Claude Opus 4.7 (1M context) <noreply@anthropic.com>
</commit_message>
<xml_diff>
--- a/legal/PATET_PLAID_PARTNERSHIP_DECK.pptx
+++ b/legal/PATET_PLAID_PARTNERSHIP_DECK.pptx
@@ -8030,7 +8030,7 @@
                 </a:solidFill>
                 <a:latin typeface="Inter"/>
               </a:rPr>
-              <a:t>4 personas unlocked by progress: Older Sibling → Drill Sergeant → Therapist → Hype Friend</a:t>
+              <a:t>4 personas unlocked by progress: Older Sibling → Strategist → Therapist → Hype Friend</a:t>
             </a:r>
           </a:p>
           <a:p>
@@ -14883,7 +14883,7 @@
                 </a:solidFill>
                 <a:latin typeface="Inter"/>
               </a:rPr>
-              <a:t>Four coach personalities unlock at module milestones (Older Sibling default → Drill Sergeant @5 → Therapist @10 → Hype Friend @15). Gamifies completion.</a:t>
+              <a:t>Four coach personalities unlock at module milestones (Older Sibling default → Strategist @5 → Therapist @10 → Hype Friend @15). Gamifies completion.</a:t>
             </a:r>
           </a:p>
         </p:txBody>

</xml_diff>

<commit_message>
docs(legal): regenerate Plaid deck — Connected/Coached replace Pro/Pro+
Tier rebrand landed in Patet (jbrock1981/Plainly commit e9768f3). Mirror
in the partnership deck:
  - Slide 4 AI-coach column: Sonnet 4.6 (Coached) + Haiku 4.5 (Free/Connected)
  - Slide 7 unique features: "121-lesson curriculum in the $2.99/mo
    Connected tier"; "strict-freemium ... behind the $2.99 Connected tier"
  - Slide 8 subtitle: "Below every competitor's flagship paid tier — by 75%."
    (was "flagship Pro")
  - Slide 8 pricing chart bars: "Patet Connected" / "Patet Coached"
  - Slide 8 right column: "Connected $2.99" / "Coached $6.99" / "Annual:
    Connected $24.99 · Coached $57.99"

Both .pptx and .pdf regenerated.

Co-Authored-By: Claude Opus 4.7 (1M context) <noreply@anthropic.com>
</commit_message>
<xml_diff>
--- a/legal/PATET_PLAID_PARTNERSHIP_DECK.pptx
+++ b/legal/PATET_PLAID_PARTNERSHIP_DECK.pptx
@@ -7974,7 +7974,7 @@
                 </a:solidFill>
                 <a:latin typeface="Inter"/>
               </a:rPr>
-              <a:t>Claude Sonnet 4.6 (Pro+) + Haiku 4.5 (Free/Pro)</a:t>
+              <a:t>Claude Sonnet 4.6 (Coached) + Haiku 4.5 (Free/Connected)</a:t>
             </a:r>
           </a:p>
           <a:p>
@@ -14735,7 +14735,7 @@
                 </a:solidFill>
                 <a:latin typeface="Inter"/>
               </a:rPr>
-              <a:t>Ramsey charges $79.99/year for curriculum alone. Patet ships 18 modules + 121 lessons in the $2.99/mo Pro tier — and unlocks an AI tutor that knows the curriculum cold.</a:t>
+              <a:t>Ramsey charges $79.99/year for curriculum alone. Patet ships 18 modules + 121 lessons in the $2.99/mo Connected tier — and unlocks an AI tutor that knows the curriculum cold.</a:t>
             </a:r>
           </a:p>
         </p:txBody>
@@ -15771,7 +15771,7 @@
                 </a:solidFill>
                 <a:latin typeface="Inter"/>
               </a:rPr>
-              <a:t>Plaid + statement upload + advanced calculators + scenarios all sit behind $2.99 Pro. Hard-gated server-side, not trial-and-revoke. Real boundary.</a:t>
+              <a:t>Plaid + statement upload + advanced calculators + scenarios all sit behind the $2.99 Connected tier. Hard-gated server-side, not trial-and-revoke. Real boundary.</a:t>
             </a:r>
           </a:p>
         </p:txBody>
@@ -15929,7 +15929,7 @@
                 </a:solidFill>
                 <a:latin typeface="Inter"/>
               </a:rPr>
-              <a:t>Below every competitor's flagship Pro — by 75%.</a:t>
+              <a:t>Below every competitor's flagship paid tier — by 75%.</a:t>
             </a:r>
           </a:p>
         </p:txBody>
@@ -17293,7 +17293,7 @@
                 </a:solidFill>
                 <a:latin typeface="Inter"/>
               </a:rPr>
-              <a:t>Patet Pro+</a:t>
+              <a:t>Patet Coached</a:t>
             </a:r>
           </a:p>
         </p:txBody>
@@ -17406,7 +17406,7 @@
                 </a:solidFill>
                 <a:latin typeface="Inter"/>
               </a:rPr>
-              <a:t>Patet Pro</a:t>
+              <a:t>Patet Connected</a:t>
             </a:r>
           </a:p>
         </p:txBody>
@@ -17595,7 +17595,7 @@
                 </a:solidFill>
                 <a:latin typeface="Inter"/>
               </a:rPr>
-              <a:t>Pro $2.99: Plaid, statement upload, all calculators, scenarios, credit tracker, 40 coach calls/day.</a:t>
+              <a:t>Connected $2.99: Plaid, statement upload, all calculators, scenarios, credit tracker, 40 coach calls/day.</a:t>
             </a:r>
           </a:p>
           <a:p>
@@ -17623,7 +17623,7 @@
                 </a:solidFill>
                 <a:latin typeface="Inter"/>
               </a:rPr>
-              <a:t>Pro+ $6.99: 80 coach calls/day, Claude Sonnet 4.6 (50/mo cap then Haiku fallback), 1,200/mo.</a:t>
+              <a:t>Coached $6.99: 80 coach calls/day, Claude Sonnet 4.6 (50/mo cap then Haiku fallback), 1,200/mo.</a:t>
             </a:r>
           </a:p>
           <a:p>
@@ -17651,7 +17651,7 @@
                 </a:solidFill>
                 <a:latin typeface="Inter"/>
               </a:rPr>
-              <a:t>Annual: Pro $24.99 (saves 31%) · Pro+ $57.99 (saves 31%).</a:t>
+              <a:t>Annual: Connected $24.99 (saves 31%) · Coached $57.99 (saves 31%).</a:t>
             </a:r>
           </a:p>
           <a:p>

</xml_diff>